<commit_message>
Add detailed manager onboarding runbook and company resource and shooting policies
</commit_message>
<xml_diff>
--- a/handover/PMP-Marketing-Department-Owner-Handover.pptx
+++ b/handover/PMP-Marketing-Department-Owner-Handover.pptx
@@ -25,6 +25,8 @@
     <p:sldId id="273" r:id="rId25"/>
     <p:sldId id="274" r:id="rId26"/>
     <p:sldId id="275" r:id="rId27"/>
+    <p:sldId id="276" r:id="rId28"/>
+    <p:sldId id="277" r:id="rId29"/>
   </p:sldIdLst>
   <p:sldSz cx="14630400" cy="8229600" type="screen4x3"/>
   <p:notesSz cx="6858000" cy="9144000"/>
@@ -1317,6 +1319,146 @@
 </file>
 
 <file path=ppt/notesSlides/notesSlide20.xml><?xml version="1.0" encoding="utf-8"?>
+<p:notes xmlns:a="http://schemas.openxmlformats.org/drawingml/2006/main" xmlns:p="http://schemas.openxmlformats.org/presentationml/2006/main" xmlns:r="http://schemas.openxmlformats.org/officeDocument/2006/relationships">
+  <p:cSld>
+    <p:spTree>
+      <p:nvGrpSpPr>
+        <p:cNvPr id="1" name=""/>
+        <p:cNvGrpSpPr/>
+        <p:nvPr/>
+      </p:nvGrpSpPr>
+      <p:grpSpPr>
+        <a:xfrm>
+          <a:off x="0" y="0"/>
+          <a:ext cx="0" cy="0"/>
+          <a:chOff x="0" y="0"/>
+          <a:chExt cx="0" cy="0"/>
+        </a:xfrm>
+      </p:grpSpPr>
+      <p:sp>
+        <p:nvSpPr>
+          <p:cNvPr id="2" name="Slide Image Placeholder 1"/>
+          <p:cNvSpPr>
+            <a:spLocks noGrp="1"/>
+          </p:cNvSpPr>
+          <p:nvPr>
+            <p:ph type="sldImg" idx="2"/>
+          </p:nvPr>
+        </p:nvSpPr>
+        <p:spPr/>
+      </p:sp>
+      <p:sp>
+        <p:nvSpPr>
+          <p:cNvPr id="3" name="Notes Placeholder 2"/>
+          <p:cNvSpPr>
+            <a:spLocks noGrp="1"/>
+          </p:cNvSpPr>
+          <p:nvPr>
+            <p:ph type="body" idx="3" sz="quarter"/>
+          </p:nvPr>
+        </p:nvSpPr>
+        <p:spPr/>
+        <p:txBody>
+          <a:bodyPr/>
+          <a:lstStyle/>
+          <a:p>
+            <a:r>
+              <a:t>Owner briefing. The DOCX SOP contains triggers, steps, exit gates and required records. Confirmed workflow derives from user instructions. Proposed controls and unresolved authority remain marked; no live access transfer, owner acceptance or actual client records are implied.</a:t>
+            </a:r>
+          </a:p>
+        </p:txBody>
+      </p:sp>
+      <p:sp>
+        <p:nvSpPr>
+          <p:cNvPr id="4" name="Slide Number Placeholder 3"/>
+          <p:cNvSpPr>
+            <a:spLocks noGrp="1"/>
+          </p:cNvSpPr>
+          <p:nvPr>
+            <p:ph type="sldNum" idx="5" sz="quarter"/>
+          </p:nvPr>
+        </p:nvSpPr>
+        <p:spPr/>
+      </p:sp>
+    </p:spTree>
+  </p:cSld>
+  <p:clrMapOvr>
+    <a:masterClrMapping/>
+  </p:clrMapOvr>
+</p:notes>
+</file>
+
+<file path=ppt/notesSlides/notesSlide21.xml><?xml version="1.0" encoding="utf-8"?>
+<p:notes xmlns:a="http://schemas.openxmlformats.org/drawingml/2006/main" xmlns:p="http://schemas.openxmlformats.org/presentationml/2006/main" xmlns:r="http://schemas.openxmlformats.org/officeDocument/2006/relationships">
+  <p:cSld>
+    <p:spTree>
+      <p:nvGrpSpPr>
+        <p:cNvPr id="1" name=""/>
+        <p:cNvGrpSpPr/>
+        <p:nvPr/>
+      </p:nvGrpSpPr>
+      <p:grpSpPr>
+        <a:xfrm>
+          <a:off x="0" y="0"/>
+          <a:ext cx="0" cy="0"/>
+          <a:chOff x="0" y="0"/>
+          <a:chExt cx="0" cy="0"/>
+        </a:xfrm>
+      </p:grpSpPr>
+      <p:sp>
+        <p:nvSpPr>
+          <p:cNvPr id="2" name="Slide Image Placeholder 1"/>
+          <p:cNvSpPr>
+            <a:spLocks noGrp="1"/>
+          </p:cNvSpPr>
+          <p:nvPr>
+            <p:ph type="sldImg" idx="2"/>
+          </p:nvPr>
+        </p:nvSpPr>
+        <p:spPr/>
+      </p:sp>
+      <p:sp>
+        <p:nvSpPr>
+          <p:cNvPr id="3" name="Notes Placeholder 2"/>
+          <p:cNvSpPr>
+            <a:spLocks noGrp="1"/>
+          </p:cNvSpPr>
+          <p:nvPr>
+            <p:ph type="body" idx="3" sz="quarter"/>
+          </p:nvPr>
+        </p:nvSpPr>
+        <p:spPr/>
+        <p:txBody>
+          <a:bodyPr/>
+          <a:lstStyle/>
+          <a:p>
+            <a:r>
+              <a:t>Owner briefing. The DOCX SOP contains triggers, steps, exit gates and required records. Confirmed workflow derives from user instructions. Proposed controls and unresolved authority remain marked; no live access transfer, owner acceptance or actual client records are implied.</a:t>
+            </a:r>
+          </a:p>
+        </p:txBody>
+      </p:sp>
+      <p:sp>
+        <p:nvSpPr>
+          <p:cNvPr id="4" name="Slide Number Placeholder 3"/>
+          <p:cNvSpPr>
+            <a:spLocks noGrp="1"/>
+          </p:cNvSpPr>
+          <p:nvPr>
+            <p:ph type="sldNum" idx="5" sz="quarter"/>
+          </p:nvPr>
+        </p:nvSpPr>
+        <p:spPr/>
+      </p:sp>
+    </p:spTree>
+  </p:cSld>
+  <p:clrMapOvr>
+    <a:masterClrMapping/>
+  </p:clrMapOvr>
+</p:notes>
+</file>
+
+<file path=ppt/notesSlides/notesSlide22.xml><?xml version="1.0" encoding="utf-8"?>
 <p:notes xmlns:a="http://schemas.openxmlformats.org/drawingml/2006/main" xmlns:p="http://schemas.openxmlformats.org/presentationml/2006/main" xmlns:r="http://schemas.openxmlformats.org/officeDocument/2006/relationships">
   <p:cSld>
     <p:spTree>
@@ -13494,6 +13636,1502 @@
     <p:bg>
       <p:bgPr>
         <a:solidFill>
+          <a:srgbClr val="F3F1EE"/>
+        </a:solidFill>
+        <a:effectLst/>
+      </p:bgPr>
+    </p:bg>
+    <p:spTree>
+      <p:nvGrpSpPr>
+        <p:cNvPr id="1" name=""/>
+        <p:cNvGrpSpPr/>
+        <p:nvPr/>
+      </p:nvGrpSpPr>
+      <p:grpSpPr/>
+      <p:sp>
+        <p:nvSpPr>
+          <p:cNvPr id="2" name="TextBox 1"/>
+          <p:cNvSpPr txBox="1"/>
+          <p:nvPr/>
+        </p:nvSpPr>
+        <p:spPr>
+          <a:xfrm>
+            <a:off x="594360" y="274320"/>
+            <a:ext cx="1097280" cy="411480"/>
+          </a:xfrm>
+          <a:prstGeom prst="rect">
+            <a:avLst/>
+          </a:prstGeom>
+          <a:noFill/>
+        </p:spPr>
+        <p:txBody>
+          <a:bodyPr wrap="square" lIns="18288" rIns="18288" tIns="0" bIns="0">
+            <a:spAutoFit/>
+          </a:bodyPr>
+          <a:lstStyle/>
+          <a:p>
+            <a:pPr>
+              <a:spcAft>
+                <a:spcPts val="800"/>
+              </a:spcAft>
+              <a:defRPr sz="2500" b="1">
+                <a:solidFill>
+                  <a:srgbClr val="7D2B42"/>
+                </a:solidFill>
+                <a:latin typeface="Montserrat"/>
+              </a:defRPr>
+            </a:pPr>
+            <a:r>
+              <a:t>PMP</a:t>
+            </a:r>
+          </a:p>
+        </p:txBody>
+      </p:sp>
+      <p:sp>
+        <p:nvSpPr>
+          <p:cNvPr id="3" name="TextBox 2"/>
+          <p:cNvSpPr txBox="1"/>
+          <p:nvPr/>
+        </p:nvSpPr>
+        <p:spPr>
+          <a:xfrm>
+            <a:off x="1828800" y="384048"/>
+            <a:ext cx="10972800" cy="274320"/>
+          </a:xfrm>
+          <a:prstGeom prst="rect">
+            <a:avLst/>
+          </a:prstGeom>
+          <a:noFill/>
+        </p:spPr>
+        <p:txBody>
+          <a:bodyPr wrap="square" lIns="18288" rIns="18288" tIns="0" bIns="0">
+            <a:spAutoFit/>
+          </a:bodyPr>
+          <a:lstStyle/>
+          <a:p>
+            <a:pPr>
+              <a:spcAft>
+                <a:spcPts val="800"/>
+              </a:spcAft>
+              <a:defRPr sz="1000" b="1">
+                <a:solidFill>
+                  <a:srgbClr val="7D2B42"/>
+                </a:solidFill>
+                <a:latin typeface="Montserrat"/>
+              </a:defRPr>
+            </a:pPr>
+            <a:r>
+              <a:t>MARKETING DEPARTMENT / OWNER HANDOVER</a:t>
+            </a:r>
+          </a:p>
+        </p:txBody>
+      </p:sp>
+      <p:sp>
+        <p:nvSpPr>
+          <p:cNvPr id="4" name="Rectangle 3"/>
+          <p:cNvSpPr/>
+          <p:nvPr/>
+        </p:nvSpPr>
+        <p:spPr>
+          <a:xfrm>
+            <a:off x="640080" y="868680"/>
+            <a:ext cx="13350240" cy="13716"/>
+          </a:xfrm>
+          <a:prstGeom prst="rect">
+            <a:avLst/>
+          </a:prstGeom>
+          <a:solidFill>
+            <a:srgbClr val="7D2B42"/>
+          </a:solidFill>
+          <a:ln>
+            <a:noFill/>
+          </a:ln>
+        </p:spPr>
+        <p:style>
+          <a:lnRef idx="1">
+            <a:schemeClr val="accent1"/>
+          </a:lnRef>
+          <a:fillRef idx="3">
+            <a:schemeClr val="accent1"/>
+          </a:fillRef>
+          <a:effectRef idx="2">
+            <a:schemeClr val="accent1"/>
+          </a:effectRef>
+          <a:fontRef idx="minor">
+            <a:schemeClr val="lt1"/>
+          </a:fontRef>
+        </p:style>
+        <p:txBody>
+          <a:bodyPr rtlCol="0" anchor="ctr"/>
+          <a:lstStyle/>
+          <a:p>
+            <a:pPr algn="ctr"/>
+          </a:p>
+        </p:txBody>
+      </p:sp>
+      <p:sp>
+        <p:nvSpPr>
+          <p:cNvPr id="5" name="TextBox 4"/>
+          <p:cNvSpPr txBox="1"/>
+          <p:nvPr/>
+        </p:nvSpPr>
+        <p:spPr>
+          <a:xfrm>
+            <a:off x="685800" y="1188720"/>
+            <a:ext cx="13258800" cy="914400"/>
+          </a:xfrm>
+          <a:prstGeom prst="rect">
+            <a:avLst/>
+          </a:prstGeom>
+          <a:noFill/>
+        </p:spPr>
+        <p:txBody>
+          <a:bodyPr wrap="square" lIns="18288" rIns="18288" tIns="0" bIns="0">
+            <a:spAutoFit/>
+          </a:bodyPr>
+          <a:lstStyle/>
+          <a:p>
+            <a:pPr>
+              <a:spcAft>
+                <a:spcPts val="800"/>
+              </a:spcAft>
+              <a:defRPr sz="3800" b="1">
+                <a:solidFill>
+                  <a:srgbClr val="7D2B42"/>
+                </a:solidFill>
+                <a:latin typeface="Bebas Neue"/>
+              </a:defRPr>
+            </a:pPr>
+            <a:r>
+              <a:t>COMPANY RESOURCES / ACCESS IS NOT UNIVERSAL</a:t>
+            </a:r>
+          </a:p>
+        </p:txBody>
+      </p:sp>
+      <p:sp>
+        <p:nvSpPr>
+          <p:cNvPr id="6" name="TextBox 5"/>
+          <p:cNvSpPr txBox="1"/>
+          <p:nvPr/>
+        </p:nvSpPr>
+        <p:spPr>
+          <a:xfrm>
+            <a:off x="685800" y="7772400"/>
+            <a:ext cx="10972800" cy="228600"/>
+          </a:xfrm>
+          <a:prstGeom prst="rect">
+            <a:avLst/>
+          </a:prstGeom>
+          <a:noFill/>
+        </p:spPr>
+        <p:txBody>
+          <a:bodyPr wrap="square" lIns="18288" rIns="18288" tIns="0" bIns="0">
+            <a:spAutoFit/>
+          </a:bodyPr>
+          <a:lstStyle/>
+          <a:p>
+            <a:pPr>
+              <a:spcAft>
+                <a:spcPts val="800"/>
+              </a:spcAft>
+              <a:defRPr sz="900" b="0">
+                <a:solidFill>
+                  <a:srgbClr val="555555"/>
+                </a:solidFill>
+                <a:latin typeface="Montserrat"/>
+              </a:defRPr>
+            </a:pPr>
+            <a:r>
+              <a:t>MODE OF OPERATIONS • V1.0 • OWNER ACCEPTANCE PENDING</a:t>
+            </a:r>
+          </a:p>
+        </p:txBody>
+      </p:sp>
+      <p:sp>
+        <p:nvSpPr>
+          <p:cNvPr id="7" name="TextBox 6"/>
+          <p:cNvSpPr txBox="1"/>
+          <p:nvPr/>
+        </p:nvSpPr>
+        <p:spPr>
+          <a:xfrm>
+            <a:off x="13350240" y="7726679"/>
+            <a:ext cx="594360" cy="274320"/>
+          </a:xfrm>
+          <a:prstGeom prst="rect">
+            <a:avLst/>
+          </a:prstGeom>
+          <a:noFill/>
+        </p:spPr>
+        <p:txBody>
+          <a:bodyPr wrap="square" lIns="18288" rIns="18288" tIns="0" bIns="0">
+            <a:spAutoFit/>
+          </a:bodyPr>
+          <a:lstStyle/>
+          <a:p>
+            <a:pPr>
+              <a:spcAft>
+                <a:spcPts val="800"/>
+              </a:spcAft>
+              <a:defRPr sz="1000" b="0">
+                <a:solidFill>
+                  <a:srgbClr val="7D2B42"/>
+                </a:solidFill>
+                <a:latin typeface="Montserrat"/>
+              </a:defRPr>
+            </a:pPr>
+            <a:r>
+              <a:t>20</a:t>
+            </a:r>
+          </a:p>
+        </p:txBody>
+      </p:sp>
+      <p:sp>
+        <p:nvSpPr>
+          <p:cNvPr id="8" name="Rectangle 7"/>
+          <p:cNvSpPr/>
+          <p:nvPr/>
+        </p:nvSpPr>
+        <p:spPr>
+          <a:xfrm>
+            <a:off x="731520" y="2331720"/>
+            <a:ext cx="3383280" cy="886968"/>
+          </a:xfrm>
+          <a:prstGeom prst="rect">
+            <a:avLst/>
+          </a:prstGeom>
+          <a:solidFill>
+            <a:srgbClr val="7D2B42"/>
+          </a:solidFill>
+          <a:ln>
+            <a:noFill/>
+          </a:ln>
+        </p:spPr>
+        <p:style>
+          <a:lnRef idx="1">
+            <a:schemeClr val="accent1"/>
+          </a:lnRef>
+          <a:fillRef idx="3">
+            <a:schemeClr val="accent1"/>
+          </a:fillRef>
+          <a:effectRef idx="2">
+            <a:schemeClr val="accent1"/>
+          </a:effectRef>
+          <a:fontRef idx="minor">
+            <a:schemeClr val="lt1"/>
+          </a:fontRef>
+        </p:style>
+        <p:txBody>
+          <a:bodyPr rtlCol="0" anchor="ctr"/>
+          <a:lstStyle/>
+          <a:p>
+            <a:pPr algn="ctr"/>
+          </a:p>
+        </p:txBody>
+      </p:sp>
+      <p:sp>
+        <p:nvSpPr>
+          <p:cNvPr id="9" name="TextBox 8"/>
+          <p:cNvSpPr txBox="1"/>
+          <p:nvPr/>
+        </p:nvSpPr>
+        <p:spPr>
+          <a:xfrm>
+            <a:off x="896112" y="2478024"/>
+            <a:ext cx="3054096" cy="758952"/>
+          </a:xfrm>
+          <a:prstGeom prst="rect">
+            <a:avLst/>
+          </a:prstGeom>
+          <a:noFill/>
+        </p:spPr>
+        <p:txBody>
+          <a:bodyPr wrap="square" lIns="18288" rIns="18288" tIns="0" bIns="0">
+            <a:spAutoFit/>
+          </a:bodyPr>
+          <a:lstStyle/>
+          <a:p>
+            <a:pPr>
+              <a:spcAft>
+                <a:spcPts val="800"/>
+              </a:spcAft>
+              <a:defRPr sz="1400" b="1">
+                <a:solidFill>
+                  <a:srgbClr val="FFFFFF"/>
+                </a:solidFill>
+                <a:latin typeface="Montserrat"/>
+              </a:defRPr>
+            </a:pPr>
+            <a:r>
+              <a:t>HIGGSFIELD</a:t>
+            </a:r>
+          </a:p>
+        </p:txBody>
+      </p:sp>
+      <p:sp>
+        <p:nvSpPr>
+          <p:cNvPr id="10" name="TextBox 9"/>
+          <p:cNvSpPr txBox="1"/>
+          <p:nvPr/>
+        </p:nvSpPr>
+        <p:spPr>
+          <a:xfrm>
+            <a:off x="4389120" y="2423160"/>
+            <a:ext cx="9464040" cy="841248"/>
+          </a:xfrm>
+          <a:prstGeom prst="rect">
+            <a:avLst/>
+          </a:prstGeom>
+          <a:noFill/>
+        </p:spPr>
+        <p:txBody>
+          <a:bodyPr wrap="square" lIns="18288" rIns="18288" tIns="0" bIns="0">
+            <a:spAutoFit/>
+          </a:bodyPr>
+          <a:lstStyle/>
+          <a:p>
+            <a:pPr>
+              <a:spcAft>
+                <a:spcPts val="800"/>
+              </a:spcAft>
+              <a:defRPr sz="1700" b="0">
+                <a:solidFill>
+                  <a:srgbClr val="202020"/>
+                </a:solidFill>
+                <a:latin typeface="Montserrat"/>
+              </a:defRPr>
+            </a:pPr>
+            <a:r>
+              <a:t>Video Editors VE-01/VE-02 ONLY. Forbidden for every other team member.</a:t>
+            </a:r>
+          </a:p>
+        </p:txBody>
+      </p:sp>
+      <p:sp>
+        <p:nvSpPr>
+          <p:cNvPr id="11" name="Rectangle 10"/>
+          <p:cNvSpPr/>
+          <p:nvPr/>
+        </p:nvSpPr>
+        <p:spPr>
+          <a:xfrm>
+            <a:off x="731520" y="3337560"/>
+            <a:ext cx="3383280" cy="886968"/>
+          </a:xfrm>
+          <a:prstGeom prst="rect">
+            <a:avLst/>
+          </a:prstGeom>
+          <a:solidFill>
+            <a:srgbClr val="7D2B42"/>
+          </a:solidFill>
+          <a:ln>
+            <a:noFill/>
+          </a:ln>
+        </p:spPr>
+        <p:style>
+          <a:lnRef idx="1">
+            <a:schemeClr val="accent1"/>
+          </a:lnRef>
+          <a:fillRef idx="3">
+            <a:schemeClr val="accent1"/>
+          </a:fillRef>
+          <a:effectRef idx="2">
+            <a:schemeClr val="accent1"/>
+          </a:effectRef>
+          <a:fontRef idx="minor">
+            <a:schemeClr val="lt1"/>
+          </a:fontRef>
+        </p:style>
+        <p:txBody>
+          <a:bodyPr rtlCol="0" anchor="ctr"/>
+          <a:lstStyle/>
+          <a:p>
+            <a:pPr algn="ctr"/>
+          </a:p>
+        </p:txBody>
+      </p:sp>
+      <p:sp>
+        <p:nvSpPr>
+          <p:cNvPr id="12" name="TextBox 11"/>
+          <p:cNvSpPr txBox="1"/>
+          <p:nvPr/>
+        </p:nvSpPr>
+        <p:spPr>
+          <a:xfrm>
+            <a:off x="896112" y="3483864"/>
+            <a:ext cx="3054096" cy="758952"/>
+          </a:xfrm>
+          <a:prstGeom prst="rect">
+            <a:avLst/>
+          </a:prstGeom>
+          <a:noFill/>
+        </p:spPr>
+        <p:txBody>
+          <a:bodyPr wrap="square" lIns="18288" rIns="18288" tIns="0" bIns="0">
+            <a:spAutoFit/>
+          </a:bodyPr>
+          <a:lstStyle/>
+          <a:p>
+            <a:pPr>
+              <a:spcAft>
+                <a:spcPts val="800"/>
+              </a:spcAft>
+              <a:defRPr sz="1400" b="1">
+                <a:solidFill>
+                  <a:srgbClr val="FFFFFF"/>
+                </a:solidFill>
+                <a:latin typeface="Montserrat"/>
+              </a:defRPr>
+            </a:pPr>
+            <a:r>
+              <a:t>CLAUDE + CHATGPT</a:t>
+            </a:r>
+          </a:p>
+        </p:txBody>
+      </p:sp>
+      <p:sp>
+        <p:nvSpPr>
+          <p:cNvPr id="13" name="TextBox 12"/>
+          <p:cNvSpPr txBox="1"/>
+          <p:nvPr/>
+        </p:nvSpPr>
+        <p:spPr>
+          <a:xfrm>
+            <a:off x="4389120" y="3429000"/>
+            <a:ext cx="9464040" cy="841248"/>
+          </a:xfrm>
+          <a:prstGeom prst="rect">
+            <a:avLst/>
+          </a:prstGeom>
+          <a:noFill/>
+        </p:spPr>
+        <p:txBody>
+          <a:bodyPr wrap="square" lIns="18288" rIns="18288" tIns="0" bIns="0">
+            <a:spAutoFit/>
+          </a:bodyPr>
+          <a:lstStyle/>
+          <a:p>
+            <a:pPr>
+              <a:spcAft>
+                <a:spcPts val="800"/>
+              </a:spcAft>
+              <a:defRPr sz="1700" b="0">
+                <a:solidFill>
+                  <a:srgbClr val="202020"/>
+                </a:solidFill>
+                <a:latin typeface="Montserrat"/>
+              </a:defRPr>
+            </a:pPr>
+            <a:r>
+              <a:t>Company-provided subscriptions; confirm named seats, licence and data-use rules.</a:t>
+            </a:r>
+          </a:p>
+        </p:txBody>
+      </p:sp>
+      <p:sp>
+        <p:nvSpPr>
+          <p:cNvPr id="14" name="Rectangle 13"/>
+          <p:cNvSpPr/>
+          <p:nvPr/>
+        </p:nvSpPr>
+        <p:spPr>
+          <a:xfrm>
+            <a:off x="731520" y="4343400"/>
+            <a:ext cx="3383280" cy="886968"/>
+          </a:xfrm>
+          <a:prstGeom prst="rect">
+            <a:avLst/>
+          </a:prstGeom>
+          <a:solidFill>
+            <a:srgbClr val="7D2B42"/>
+          </a:solidFill>
+          <a:ln>
+            <a:noFill/>
+          </a:ln>
+        </p:spPr>
+        <p:style>
+          <a:lnRef idx="1">
+            <a:schemeClr val="accent1"/>
+          </a:lnRef>
+          <a:fillRef idx="3">
+            <a:schemeClr val="accent1"/>
+          </a:fillRef>
+          <a:effectRef idx="2">
+            <a:schemeClr val="accent1"/>
+          </a:effectRef>
+          <a:fontRef idx="minor">
+            <a:schemeClr val="lt1"/>
+          </a:fontRef>
+        </p:style>
+        <p:txBody>
+          <a:bodyPr rtlCol="0" anchor="ctr"/>
+          <a:lstStyle/>
+          <a:p>
+            <a:pPr algn="ctr"/>
+          </a:p>
+        </p:txBody>
+      </p:sp>
+      <p:sp>
+        <p:nvSpPr>
+          <p:cNvPr id="15" name="TextBox 14"/>
+          <p:cNvSpPr txBox="1"/>
+          <p:nvPr/>
+        </p:nvSpPr>
+        <p:spPr>
+          <a:xfrm>
+            <a:off x="896112" y="4489704"/>
+            <a:ext cx="3054096" cy="758952"/>
+          </a:xfrm>
+          <a:prstGeom prst="rect">
+            <a:avLst/>
+          </a:prstGeom>
+          <a:noFill/>
+        </p:spPr>
+        <p:txBody>
+          <a:bodyPr wrap="square" lIns="18288" rIns="18288" tIns="0" bIns="0">
+            <a:spAutoFit/>
+          </a:bodyPr>
+          <a:lstStyle/>
+          <a:p>
+            <a:pPr>
+              <a:spcAft>
+                <a:spcPts val="800"/>
+              </a:spcAft>
+              <a:defRPr sz="1400" b="1">
+                <a:solidFill>
+                  <a:srgbClr val="FFFFFF"/>
+                </a:solidFill>
+                <a:latin typeface="Montserrat"/>
+              </a:defRPr>
+            </a:pPr>
+            <a:r>
+              <a:t>CANVA + ADOBE</a:t>
+            </a:r>
+          </a:p>
+        </p:txBody>
+      </p:sp>
+      <p:sp>
+        <p:nvSpPr>
+          <p:cNvPr id="16" name="TextBox 15"/>
+          <p:cNvSpPr txBox="1"/>
+          <p:nvPr/>
+        </p:nvSpPr>
+        <p:spPr>
+          <a:xfrm>
+            <a:off x="4389120" y="4434840"/>
+            <a:ext cx="9464040" cy="841248"/>
+          </a:xfrm>
+          <a:prstGeom prst="rect">
+            <a:avLst/>
+          </a:prstGeom>
+          <a:noFill/>
+        </p:spPr>
+        <p:txBody>
+          <a:bodyPr wrap="square" lIns="18288" rIns="18288" tIns="0" bIns="0">
+            <a:spAutoFit/>
+          </a:bodyPr>
+          <a:lstStyle/>
+          <a:p>
+            <a:pPr>
+              <a:spcAft>
+                <a:spcPts val="800"/>
+              </a:spcAft>
+              <a:defRPr sz="1700" b="0">
+                <a:solidFill>
+                  <a:srgbClr val="202020"/>
+                </a:solidFill>
+                <a:latin typeface="Montserrat"/>
+              </a:defRPr>
+            </a:pPr>
+            <a:r>
+              <a:t>Company-provided software; exact applications and seat assignments remain to confirm.</a:t>
+            </a:r>
+          </a:p>
+        </p:txBody>
+      </p:sp>
+      <p:sp>
+        <p:nvSpPr>
+          <p:cNvPr id="17" name="Rectangle 16"/>
+          <p:cNvSpPr/>
+          <p:nvPr/>
+        </p:nvSpPr>
+        <p:spPr>
+          <a:xfrm>
+            <a:off x="731520" y="5349240"/>
+            <a:ext cx="3383280" cy="886968"/>
+          </a:xfrm>
+          <a:prstGeom prst="rect">
+            <a:avLst/>
+          </a:prstGeom>
+          <a:solidFill>
+            <a:srgbClr val="7D2B42"/>
+          </a:solidFill>
+          <a:ln>
+            <a:noFill/>
+          </a:ln>
+        </p:spPr>
+        <p:style>
+          <a:lnRef idx="1">
+            <a:schemeClr val="accent1"/>
+          </a:lnRef>
+          <a:fillRef idx="3">
+            <a:schemeClr val="accent1"/>
+          </a:fillRef>
+          <a:effectRef idx="2">
+            <a:schemeClr val="accent1"/>
+          </a:effectRef>
+          <a:fontRef idx="minor">
+            <a:schemeClr val="lt1"/>
+          </a:fontRef>
+        </p:style>
+        <p:txBody>
+          <a:bodyPr rtlCol="0" anchor="ctr"/>
+          <a:lstStyle/>
+          <a:p>
+            <a:pPr algn="ctr"/>
+          </a:p>
+        </p:txBody>
+      </p:sp>
+      <p:sp>
+        <p:nvSpPr>
+          <p:cNvPr id="18" name="TextBox 17"/>
+          <p:cNvSpPr txBox="1"/>
+          <p:nvPr/>
+        </p:nvSpPr>
+        <p:spPr>
+          <a:xfrm>
+            <a:off x="896112" y="5495544"/>
+            <a:ext cx="3054096" cy="758952"/>
+          </a:xfrm>
+          <a:prstGeom prst="rect">
+            <a:avLst/>
+          </a:prstGeom>
+          <a:noFill/>
+        </p:spPr>
+        <p:txBody>
+          <a:bodyPr wrap="square" lIns="18288" rIns="18288" tIns="0" bIns="0">
+            <a:spAutoFit/>
+          </a:bodyPr>
+          <a:lstStyle/>
+          <a:p>
+            <a:pPr>
+              <a:spcAft>
+                <a:spcPts val="800"/>
+              </a:spcAft>
+              <a:defRPr sz="1400" b="1">
+                <a:solidFill>
+                  <a:srgbClr val="FFFFFF"/>
+                </a:solidFill>
+                <a:latin typeface="Montserrat"/>
+              </a:defRPr>
+            </a:pPr>
+            <a:r>
+              <a:t>HARD DRIVES</a:t>
+            </a:r>
+          </a:p>
+        </p:txBody>
+      </p:sp>
+      <p:sp>
+        <p:nvSpPr>
+          <p:cNvPr id="19" name="TextBox 18"/>
+          <p:cNvSpPr txBox="1"/>
+          <p:nvPr/>
+        </p:nvSpPr>
+        <p:spPr>
+          <a:xfrm>
+            <a:off x="4389120" y="5440679"/>
+            <a:ext cx="9464040" cy="841248"/>
+          </a:xfrm>
+          <a:prstGeom prst="rect">
+            <a:avLst/>
+          </a:prstGeom>
+          <a:noFill/>
+        </p:spPr>
+        <p:txBody>
+          <a:bodyPr wrap="square" lIns="18288" rIns="18288" tIns="0" bIns="0">
+            <a:spAutoFit/>
+          </a:bodyPr>
+          <a:lstStyle/>
+          <a:p>
+            <a:pPr>
+              <a:spcAft>
+                <a:spcPts val="800"/>
+              </a:spcAft>
+              <a:defRPr sz="1700" b="0">
+                <a:solidFill>
+                  <a:srgbClr val="202020"/>
+                </a:solidFill>
+                <a:latin typeface="Montserrat"/>
+              </a:defRPr>
+            </a:pPr>
+            <a:r>
+              <a:t>Several company drives exist. Register asset, location, contents and named custodian; custody not yet assigned here.</a:t>
+            </a:r>
+          </a:p>
+        </p:txBody>
+      </p:sp>
+    </p:spTree>
+  </p:cSld>
+  <p:clrMapOvr>
+    <a:masterClrMapping/>
+  </p:clrMapOvr>
+</p:sld>
+</file>
+
+<file path=ppt/slides/slide21.xml><?xml version="1.0" encoding="utf-8"?>
+<p:sld xmlns:a="http://schemas.openxmlformats.org/drawingml/2006/main" xmlns:p="http://schemas.openxmlformats.org/presentationml/2006/main" xmlns:r="http://schemas.openxmlformats.org/officeDocument/2006/relationships">
+  <p:cSld>
+    <p:bg>
+      <p:bgPr>
+        <a:solidFill>
+          <a:srgbClr val="F3F1EE"/>
+        </a:solidFill>
+        <a:effectLst/>
+      </p:bgPr>
+    </p:bg>
+    <p:spTree>
+      <p:nvGrpSpPr>
+        <p:cNvPr id="1" name=""/>
+        <p:cNvGrpSpPr/>
+        <p:nvPr/>
+      </p:nvGrpSpPr>
+      <p:grpSpPr/>
+      <p:sp>
+        <p:nvSpPr>
+          <p:cNvPr id="2" name="TextBox 1"/>
+          <p:cNvSpPr txBox="1"/>
+          <p:nvPr/>
+        </p:nvSpPr>
+        <p:spPr>
+          <a:xfrm>
+            <a:off x="594360" y="274320"/>
+            <a:ext cx="1097280" cy="411480"/>
+          </a:xfrm>
+          <a:prstGeom prst="rect">
+            <a:avLst/>
+          </a:prstGeom>
+          <a:noFill/>
+        </p:spPr>
+        <p:txBody>
+          <a:bodyPr wrap="square" lIns="18288" rIns="18288" tIns="0" bIns="0">
+            <a:spAutoFit/>
+          </a:bodyPr>
+          <a:lstStyle/>
+          <a:p>
+            <a:pPr>
+              <a:spcAft>
+                <a:spcPts val="800"/>
+              </a:spcAft>
+              <a:defRPr sz="2500" b="1">
+                <a:solidFill>
+                  <a:srgbClr val="7D2B42"/>
+                </a:solidFill>
+                <a:latin typeface="Montserrat"/>
+              </a:defRPr>
+            </a:pPr>
+            <a:r>
+              <a:t>PMP</a:t>
+            </a:r>
+          </a:p>
+        </p:txBody>
+      </p:sp>
+      <p:sp>
+        <p:nvSpPr>
+          <p:cNvPr id="3" name="TextBox 2"/>
+          <p:cNvSpPr txBox="1"/>
+          <p:nvPr/>
+        </p:nvSpPr>
+        <p:spPr>
+          <a:xfrm>
+            <a:off x="1828800" y="384048"/>
+            <a:ext cx="10972800" cy="274320"/>
+          </a:xfrm>
+          <a:prstGeom prst="rect">
+            <a:avLst/>
+          </a:prstGeom>
+          <a:noFill/>
+        </p:spPr>
+        <p:txBody>
+          <a:bodyPr wrap="square" lIns="18288" rIns="18288" tIns="0" bIns="0">
+            <a:spAutoFit/>
+          </a:bodyPr>
+          <a:lstStyle/>
+          <a:p>
+            <a:pPr>
+              <a:spcAft>
+                <a:spcPts val="800"/>
+              </a:spcAft>
+              <a:defRPr sz="1000" b="1">
+                <a:solidFill>
+                  <a:srgbClr val="7D2B42"/>
+                </a:solidFill>
+                <a:latin typeface="Montserrat"/>
+              </a:defRPr>
+            </a:pPr>
+            <a:r>
+              <a:t>MARKETING DEPARTMENT / OWNER HANDOVER</a:t>
+            </a:r>
+          </a:p>
+        </p:txBody>
+      </p:sp>
+      <p:sp>
+        <p:nvSpPr>
+          <p:cNvPr id="4" name="Rectangle 3"/>
+          <p:cNvSpPr/>
+          <p:nvPr/>
+        </p:nvSpPr>
+        <p:spPr>
+          <a:xfrm>
+            <a:off x="640080" y="868680"/>
+            <a:ext cx="13350240" cy="13716"/>
+          </a:xfrm>
+          <a:prstGeom prst="rect">
+            <a:avLst/>
+          </a:prstGeom>
+          <a:solidFill>
+            <a:srgbClr val="7D2B42"/>
+          </a:solidFill>
+          <a:ln>
+            <a:noFill/>
+          </a:ln>
+        </p:spPr>
+        <p:style>
+          <a:lnRef idx="1">
+            <a:schemeClr val="accent1"/>
+          </a:lnRef>
+          <a:fillRef idx="3">
+            <a:schemeClr val="accent1"/>
+          </a:fillRef>
+          <a:effectRef idx="2">
+            <a:schemeClr val="accent1"/>
+          </a:effectRef>
+          <a:fontRef idx="minor">
+            <a:schemeClr val="lt1"/>
+          </a:fontRef>
+        </p:style>
+        <p:txBody>
+          <a:bodyPr rtlCol="0" anchor="ctr"/>
+          <a:lstStyle/>
+          <a:p>
+            <a:pPr algn="ctr"/>
+          </a:p>
+        </p:txBody>
+      </p:sp>
+      <p:sp>
+        <p:nvSpPr>
+          <p:cNvPr id="5" name="TextBox 4"/>
+          <p:cNvSpPr txBox="1"/>
+          <p:nvPr/>
+        </p:nvSpPr>
+        <p:spPr>
+          <a:xfrm>
+            <a:off x="685800" y="1188720"/>
+            <a:ext cx="13258800" cy="914400"/>
+          </a:xfrm>
+          <a:prstGeom prst="rect">
+            <a:avLst/>
+          </a:prstGeom>
+          <a:noFill/>
+        </p:spPr>
+        <p:txBody>
+          <a:bodyPr wrap="square" lIns="18288" rIns="18288" tIns="0" bIns="0">
+            <a:spAutoFit/>
+          </a:bodyPr>
+          <a:lstStyle/>
+          <a:p>
+            <a:pPr>
+              <a:spcAft>
+                <a:spcPts val="800"/>
+              </a:spcAft>
+              <a:defRPr sz="3800" b="1">
+                <a:solidFill>
+                  <a:srgbClr val="7D2B42"/>
+                </a:solidFill>
+                <a:latin typeface="Bebas Neue"/>
+              </a:defRPr>
+            </a:pPr>
+            <a:r>
+              <a:t>SHOOTING OPERATIONS / PEOPLE, DATA AND EQUIPMENT</a:t>
+            </a:r>
+          </a:p>
+        </p:txBody>
+      </p:sp>
+      <p:sp>
+        <p:nvSpPr>
+          <p:cNvPr id="6" name="TextBox 5"/>
+          <p:cNvSpPr txBox="1"/>
+          <p:nvPr/>
+        </p:nvSpPr>
+        <p:spPr>
+          <a:xfrm>
+            <a:off x="685800" y="7772400"/>
+            <a:ext cx="10972800" cy="228600"/>
+          </a:xfrm>
+          <a:prstGeom prst="rect">
+            <a:avLst/>
+          </a:prstGeom>
+          <a:noFill/>
+        </p:spPr>
+        <p:txBody>
+          <a:bodyPr wrap="square" lIns="18288" rIns="18288" tIns="0" bIns="0">
+            <a:spAutoFit/>
+          </a:bodyPr>
+          <a:lstStyle/>
+          <a:p>
+            <a:pPr>
+              <a:spcAft>
+                <a:spcPts val="800"/>
+              </a:spcAft>
+              <a:defRPr sz="900" b="0">
+                <a:solidFill>
+                  <a:srgbClr val="555555"/>
+                </a:solidFill>
+                <a:latin typeface="Montserrat"/>
+              </a:defRPr>
+            </a:pPr>
+            <a:r>
+              <a:t>MODE OF OPERATIONS • V1.0 • OWNER ACCEPTANCE PENDING</a:t>
+            </a:r>
+          </a:p>
+        </p:txBody>
+      </p:sp>
+      <p:sp>
+        <p:nvSpPr>
+          <p:cNvPr id="7" name="TextBox 6"/>
+          <p:cNvSpPr txBox="1"/>
+          <p:nvPr/>
+        </p:nvSpPr>
+        <p:spPr>
+          <a:xfrm>
+            <a:off x="13350240" y="7726679"/>
+            <a:ext cx="594360" cy="274320"/>
+          </a:xfrm>
+          <a:prstGeom prst="rect">
+            <a:avLst/>
+          </a:prstGeom>
+          <a:noFill/>
+        </p:spPr>
+        <p:txBody>
+          <a:bodyPr wrap="square" lIns="18288" rIns="18288" tIns="0" bIns="0">
+            <a:spAutoFit/>
+          </a:bodyPr>
+          <a:lstStyle/>
+          <a:p>
+            <a:pPr>
+              <a:spcAft>
+                <a:spcPts val="800"/>
+              </a:spcAft>
+              <a:defRPr sz="1000" b="0">
+                <a:solidFill>
+                  <a:srgbClr val="7D2B42"/>
+                </a:solidFill>
+                <a:latin typeface="Montserrat"/>
+              </a:defRPr>
+            </a:pPr>
+            <a:r>
+              <a:t>21</a:t>
+            </a:r>
+          </a:p>
+        </p:txBody>
+      </p:sp>
+      <p:sp>
+        <p:nvSpPr>
+          <p:cNvPr id="8" name="Rectangle 7"/>
+          <p:cNvSpPr/>
+          <p:nvPr/>
+        </p:nvSpPr>
+        <p:spPr>
+          <a:xfrm>
+            <a:off x="731520" y="2331720"/>
+            <a:ext cx="3383280" cy="886968"/>
+          </a:xfrm>
+          <a:prstGeom prst="rect">
+            <a:avLst/>
+          </a:prstGeom>
+          <a:solidFill>
+            <a:srgbClr val="7D2B42"/>
+          </a:solidFill>
+          <a:ln>
+            <a:noFill/>
+          </a:ln>
+        </p:spPr>
+        <p:style>
+          <a:lnRef idx="1">
+            <a:schemeClr val="accent1"/>
+          </a:lnRef>
+          <a:fillRef idx="3">
+            <a:schemeClr val="accent1"/>
+          </a:fillRef>
+          <a:effectRef idx="2">
+            <a:schemeClr val="accent1"/>
+          </a:effectRef>
+          <a:fontRef idx="minor">
+            <a:schemeClr val="lt1"/>
+          </a:fontRef>
+        </p:style>
+        <p:txBody>
+          <a:bodyPr rtlCol="0" anchor="ctr"/>
+          <a:lstStyle/>
+          <a:p>
+            <a:pPr algn="ctr"/>
+          </a:p>
+        </p:txBody>
+      </p:sp>
+      <p:sp>
+        <p:nvSpPr>
+          <p:cNvPr id="9" name="TextBox 8"/>
+          <p:cNvSpPr txBox="1"/>
+          <p:nvPr/>
+        </p:nvSpPr>
+        <p:spPr>
+          <a:xfrm>
+            <a:off x="896112" y="2478024"/>
+            <a:ext cx="3054096" cy="758952"/>
+          </a:xfrm>
+          <a:prstGeom prst="rect">
+            <a:avLst/>
+          </a:prstGeom>
+          <a:noFill/>
+        </p:spPr>
+        <p:txBody>
+          <a:bodyPr wrap="square" lIns="18288" rIns="18288" tIns="0" bIns="0">
+            <a:spAutoFit/>
+          </a:bodyPr>
+          <a:lstStyle/>
+          <a:p>
+            <a:pPr>
+              <a:spcAft>
+                <a:spcPts val="800"/>
+              </a:spcAft>
+              <a:defRPr sz="1400" b="1">
+                <a:solidFill>
+                  <a:srgbClr val="FFFFFF"/>
+                </a:solidFill>
+                <a:latin typeface="Montserrat"/>
+              </a:defRPr>
+            </a:pPr>
+            <a:r>
+              <a:t>AM COORDINATION</a:t>
+            </a:r>
+          </a:p>
+        </p:txBody>
+      </p:sp>
+      <p:sp>
+        <p:nvSpPr>
+          <p:cNvPr id="10" name="TextBox 9"/>
+          <p:cNvSpPr txBox="1"/>
+          <p:nvPr/>
+        </p:nvSpPr>
+        <p:spPr>
+          <a:xfrm>
+            <a:off x="4389120" y="2423160"/>
+            <a:ext cx="9464040" cy="841248"/>
+          </a:xfrm>
+          <a:prstGeom prst="rect">
+            <a:avLst/>
+          </a:prstGeom>
+          <a:noFill/>
+        </p:spPr>
+        <p:txBody>
+          <a:bodyPr wrap="square" lIns="18288" rIns="18288" tIns="0" bIns="0">
+            <a:spAutoFit/>
+          </a:bodyPr>
+          <a:lstStyle/>
+          <a:p>
+            <a:pPr>
+              <a:spcAft>
+                <a:spcPts val="800"/>
+              </a:spcAft>
+              <a:defRPr sz="1700" b="0">
+                <a:solidFill>
+                  <a:srgbClr val="202020"/>
+                </a:solidFill>
+                <a:latin typeface="Montserrat"/>
+              </a:defRPr>
+            </a:pPr>
+            <a:r>
+              <a:t>Arrange outsourced video/photo team, podcast guests and PR person.</a:t>
+            </a:r>
+          </a:p>
+        </p:txBody>
+      </p:sp>
+      <p:sp>
+        <p:nvSpPr>
+          <p:cNvPr id="11" name="Rectangle 10"/>
+          <p:cNvSpPr/>
+          <p:nvPr/>
+        </p:nvSpPr>
+        <p:spPr>
+          <a:xfrm>
+            <a:off x="731520" y="3337560"/>
+            <a:ext cx="3383280" cy="886968"/>
+          </a:xfrm>
+          <a:prstGeom prst="rect">
+            <a:avLst/>
+          </a:prstGeom>
+          <a:solidFill>
+            <a:srgbClr val="7D2B42"/>
+          </a:solidFill>
+          <a:ln>
+            <a:noFill/>
+          </a:ln>
+        </p:spPr>
+        <p:style>
+          <a:lnRef idx="1">
+            <a:schemeClr val="accent1"/>
+          </a:lnRef>
+          <a:fillRef idx="3">
+            <a:schemeClr val="accent1"/>
+          </a:fillRef>
+          <a:effectRef idx="2">
+            <a:schemeClr val="accent1"/>
+          </a:effectRef>
+          <a:fontRef idx="minor">
+            <a:schemeClr val="lt1"/>
+          </a:fontRef>
+        </p:style>
+        <p:txBody>
+          <a:bodyPr rtlCol="0" anchor="ctr"/>
+          <a:lstStyle/>
+          <a:p>
+            <a:pPr algn="ctr"/>
+          </a:p>
+        </p:txBody>
+      </p:sp>
+      <p:sp>
+        <p:nvSpPr>
+          <p:cNvPr id="12" name="TextBox 11"/>
+          <p:cNvSpPr txBox="1"/>
+          <p:nvPr/>
+        </p:nvSpPr>
+        <p:spPr>
+          <a:xfrm>
+            <a:off x="896112" y="3483864"/>
+            <a:ext cx="3054096" cy="758952"/>
+          </a:xfrm>
+          <a:prstGeom prst="rect">
+            <a:avLst/>
+          </a:prstGeom>
+          <a:noFill/>
+        </p:spPr>
+        <p:txBody>
+          <a:bodyPr wrap="square" lIns="18288" rIns="18288" tIns="0" bIns="0">
+            <a:spAutoFit/>
+          </a:bodyPr>
+          <a:lstStyle/>
+          <a:p>
+            <a:pPr>
+              <a:spcAft>
+                <a:spcPts val="800"/>
+              </a:spcAft>
+              <a:defRPr sz="1400" b="1">
+                <a:solidFill>
+                  <a:srgbClr val="FFFFFF"/>
+                </a:solidFill>
+                <a:latin typeface="Montserrat"/>
+              </a:defRPr>
+            </a:pPr>
+            <a:r>
+              <a:t>SM DATA HANDOFF</a:t>
+            </a:r>
+          </a:p>
+        </p:txBody>
+      </p:sp>
+      <p:sp>
+        <p:nvSpPr>
+          <p:cNvPr id="13" name="TextBox 12"/>
+          <p:cNvSpPr txBox="1"/>
+          <p:nvPr/>
+        </p:nvSpPr>
+        <p:spPr>
+          <a:xfrm>
+            <a:off x="4389120" y="3429000"/>
+            <a:ext cx="9464040" cy="841248"/>
+          </a:xfrm>
+          <a:prstGeom prst="rect">
+            <a:avLst/>
+          </a:prstGeom>
+          <a:noFill/>
+        </p:spPr>
+        <p:txBody>
+          <a:bodyPr wrap="square" lIns="18288" rIns="18288" tIns="0" bIns="0">
+            <a:spAutoFit/>
+          </a:bodyPr>
+          <a:lstStyle/>
+          <a:p>
+            <a:pPr>
+              <a:spcAft>
+                <a:spcPts val="800"/>
+              </a:spcAft>
+              <a:defRPr sz="1700" b="0">
+                <a:solidFill>
+                  <a:srgbClr val="202020"/>
+                </a:solidFill>
+                <a:latin typeface="Montserrat"/>
+              </a:defRPr>
+            </a:pPr>
+            <a:r>
+              <a:t>Collect footage/photos from videographer/photographer; hand to assigned editors/designers.</a:t>
+            </a:r>
+          </a:p>
+        </p:txBody>
+      </p:sp>
+      <p:sp>
+        <p:nvSpPr>
+          <p:cNvPr id="14" name="Rectangle 13"/>
+          <p:cNvSpPr/>
+          <p:nvPr/>
+        </p:nvSpPr>
+        <p:spPr>
+          <a:xfrm>
+            <a:off x="731520" y="4343400"/>
+            <a:ext cx="3383280" cy="886968"/>
+          </a:xfrm>
+          <a:prstGeom prst="rect">
+            <a:avLst/>
+          </a:prstGeom>
+          <a:solidFill>
+            <a:srgbClr val="7D2B42"/>
+          </a:solidFill>
+          <a:ln>
+            <a:noFill/>
+          </a:ln>
+        </p:spPr>
+        <p:style>
+          <a:lnRef idx="1">
+            <a:schemeClr val="accent1"/>
+          </a:lnRef>
+          <a:fillRef idx="3">
+            <a:schemeClr val="accent1"/>
+          </a:fillRef>
+          <a:effectRef idx="2">
+            <a:schemeClr val="accent1"/>
+          </a:effectRef>
+          <a:fontRef idx="minor">
+            <a:schemeClr val="lt1"/>
+          </a:fontRef>
+        </p:style>
+        <p:txBody>
+          <a:bodyPr rtlCol="0" anchor="ctr"/>
+          <a:lstStyle/>
+          <a:p>
+            <a:pPr algn="ctr"/>
+          </a:p>
+        </p:txBody>
+      </p:sp>
+      <p:sp>
+        <p:nvSpPr>
+          <p:cNvPr id="15" name="TextBox 14"/>
+          <p:cNvSpPr txBox="1"/>
+          <p:nvPr/>
+        </p:nvSpPr>
+        <p:spPr>
+          <a:xfrm>
+            <a:off x="896112" y="4489704"/>
+            <a:ext cx="3054096" cy="758952"/>
+          </a:xfrm>
+          <a:prstGeom prst="rect">
+            <a:avLst/>
+          </a:prstGeom>
+          <a:noFill/>
+        </p:spPr>
+        <p:txBody>
+          <a:bodyPr wrap="square" lIns="18288" rIns="18288" tIns="0" bIns="0">
+            <a:spAutoFit/>
+          </a:bodyPr>
+          <a:lstStyle/>
+          <a:p>
+            <a:pPr>
+              <a:spcAft>
+                <a:spcPts val="800"/>
+              </a:spcAft>
+              <a:defRPr sz="1400" b="1">
+                <a:solidFill>
+                  <a:srgbClr val="FFFFFF"/>
+                </a:solidFill>
+                <a:latin typeface="Montserrat"/>
+              </a:defRPr>
+            </a:pPr>
+            <a:r>
+              <a:t>SM ACCOUNTABILITY</a:t>
+            </a:r>
+          </a:p>
+        </p:txBody>
+      </p:sp>
+      <p:sp>
+        <p:nvSpPr>
+          <p:cNvPr id="16" name="TextBox 15"/>
+          <p:cNvSpPr txBox="1"/>
+          <p:nvPr/>
+        </p:nvSpPr>
+        <p:spPr>
+          <a:xfrm>
+            <a:off x="4389120" y="4434840"/>
+            <a:ext cx="9464040" cy="841248"/>
+          </a:xfrm>
+          <a:prstGeom prst="rect">
+            <a:avLst/>
+          </a:prstGeom>
+          <a:noFill/>
+        </p:spPr>
+        <p:txBody>
+          <a:bodyPr wrap="square" lIns="18288" rIns="18288" tIns="0" bIns="0">
+            <a:spAutoFit/>
+          </a:bodyPr>
+          <a:lstStyle/>
+          <a:p>
+            <a:pPr>
+              <a:spcAft>
+                <a:spcPts val="800"/>
+              </a:spcAft>
+              <a:defRPr sz="1700" b="0">
+                <a:solidFill>
+                  <a:srgbClr val="202020"/>
+                </a:solidFill>
+                <a:latin typeface="Montserrat"/>
+              </a:defRPr>
+            </a:pPr>
+            <a:r>
+              <a:t>Full accountability for memory cards and studio tools; capture behind-the-scenes content.</a:t>
+            </a:r>
+          </a:p>
+        </p:txBody>
+      </p:sp>
+      <p:sp>
+        <p:nvSpPr>
+          <p:cNvPr id="17" name="Rectangle 16"/>
+          <p:cNvSpPr/>
+          <p:nvPr/>
+        </p:nvSpPr>
+        <p:spPr>
+          <a:xfrm>
+            <a:off x="731520" y="5349240"/>
+            <a:ext cx="3383280" cy="886968"/>
+          </a:xfrm>
+          <a:prstGeom prst="rect">
+            <a:avLst/>
+          </a:prstGeom>
+          <a:solidFill>
+            <a:srgbClr val="7D2B42"/>
+          </a:solidFill>
+          <a:ln>
+            <a:noFill/>
+          </a:ln>
+        </p:spPr>
+        <p:style>
+          <a:lnRef idx="1">
+            <a:schemeClr val="accent1"/>
+          </a:lnRef>
+          <a:fillRef idx="3">
+            <a:schemeClr val="accent1"/>
+          </a:fillRef>
+          <a:effectRef idx="2">
+            <a:schemeClr val="accent1"/>
+          </a:effectRef>
+          <a:fontRef idx="minor">
+            <a:schemeClr val="lt1"/>
+          </a:fontRef>
+        </p:style>
+        <p:txBody>
+          <a:bodyPr rtlCol="0" anchor="ctr"/>
+          <a:lstStyle/>
+          <a:p>
+            <a:pPr algn="ctr"/>
+          </a:p>
+        </p:txBody>
+      </p:sp>
+      <p:sp>
+        <p:nvSpPr>
+          <p:cNvPr id="18" name="TextBox 17"/>
+          <p:cNvSpPr txBox="1"/>
+          <p:nvPr/>
+        </p:nvSpPr>
+        <p:spPr>
+          <a:xfrm>
+            <a:off x="896112" y="5495544"/>
+            <a:ext cx="3054096" cy="758952"/>
+          </a:xfrm>
+          <a:prstGeom prst="rect">
+            <a:avLst/>
+          </a:prstGeom>
+          <a:noFill/>
+        </p:spPr>
+        <p:txBody>
+          <a:bodyPr wrap="square" lIns="18288" rIns="18288" tIns="0" bIns="0">
+            <a:spAutoFit/>
+          </a:bodyPr>
+          <a:lstStyle/>
+          <a:p>
+            <a:pPr>
+              <a:spcAft>
+                <a:spcPts val="800"/>
+              </a:spcAft>
+              <a:defRPr sz="1400" b="1">
+                <a:solidFill>
+                  <a:srgbClr val="FFFFFF"/>
+                </a:solidFill>
+                <a:latin typeface="Montserrat"/>
+              </a:defRPr>
+            </a:pPr>
+            <a:r>
+              <a:t>RECOMMENDED RECORDS</a:t>
+            </a:r>
+          </a:p>
+        </p:txBody>
+      </p:sp>
+      <p:sp>
+        <p:nvSpPr>
+          <p:cNvPr id="19" name="TextBox 18"/>
+          <p:cNvSpPr txBox="1"/>
+          <p:nvPr/>
+        </p:nvSpPr>
+        <p:spPr>
+          <a:xfrm>
+            <a:off x="4389120" y="5440679"/>
+            <a:ext cx="9464040" cy="841248"/>
+          </a:xfrm>
+          <a:prstGeom prst="rect">
+            <a:avLst/>
+          </a:prstGeom>
+          <a:noFill/>
+        </p:spPr>
+        <p:txBody>
+          <a:bodyPr wrap="square" lIns="18288" rIns="18288" tIns="0" bIns="0">
+            <a:spAutoFit/>
+          </a:bodyPr>
+          <a:lstStyle/>
+          <a:p>
+            <a:pPr>
+              <a:spcAft>
+                <a:spcPts val="800"/>
+              </a:spcAft>
+              <a:defRPr sz="1700" b="0">
+                <a:solidFill>
+                  <a:srgbClr val="202020"/>
+                </a:solidFill>
+                <a:latin typeface="Montserrat"/>
+              </a:defRPr>
+            </a:pPr>
+            <a:r>
+              <a:t>Shoot brief, asset issue/return, transfer reference, receiver check and backup/custody confirmation.</a:t>
+            </a:r>
+          </a:p>
+        </p:txBody>
+      </p:sp>
+    </p:spTree>
+  </p:cSld>
+  <p:clrMapOvr>
+    <a:masterClrMapping/>
+  </p:clrMapOvr>
+</p:sld>
+</file>
+
+<file path=ppt/slides/slide22.xml><?xml version="1.0" encoding="utf-8"?>
+<p:sld xmlns:a="http://schemas.openxmlformats.org/drawingml/2006/main" xmlns:p="http://schemas.openxmlformats.org/presentationml/2006/main" xmlns:r="http://schemas.openxmlformats.org/officeDocument/2006/relationships">
+  <p:cSld>
+    <p:bg>
+      <p:bgPr>
+        <a:solidFill>
           <a:srgbClr val="7D2B42"/>
         </a:solidFill>
         <a:effectLst/>
@@ -13739,7 +15377,7 @@
               </a:defRPr>
             </a:pPr>
             <a:r>
-              <a:t>20</a:t>
+              <a:t>22</a:t>
             </a:r>
           </a:p>
         </p:txBody>

</xml_diff>

<commit_message>
Deliver English and Arabic operating packs with monthly appraisals
</commit_message>
<xml_diff>
--- a/handover/PMP-Marketing-Department-Owner-Handover.pptx
+++ b/handover/PMP-Marketing-Department-Owner-Handover.pptx
@@ -27,6 +27,7 @@
     <p:sldId id="275" r:id="rId27"/>
     <p:sldId id="276" r:id="rId28"/>
     <p:sldId id="277" r:id="rId29"/>
+    <p:sldId id="278" r:id="rId30"/>
   </p:sldIdLst>
   <p:sldSz cx="14630400" cy="8229600" type="screen4x3"/>
   <p:notesSz cx="6858000" cy="9144000"/>
@@ -1459,6 +1460,76 @@
 </file>
 
 <file path=ppt/notesSlides/notesSlide22.xml><?xml version="1.0" encoding="utf-8"?>
+<p:notes xmlns:a="http://schemas.openxmlformats.org/drawingml/2006/main" xmlns:p="http://schemas.openxmlformats.org/presentationml/2006/main" xmlns:r="http://schemas.openxmlformats.org/officeDocument/2006/relationships">
+  <p:cSld>
+    <p:spTree>
+      <p:nvGrpSpPr>
+        <p:cNvPr id="1" name=""/>
+        <p:cNvGrpSpPr/>
+        <p:nvPr/>
+      </p:nvGrpSpPr>
+      <p:grpSpPr>
+        <a:xfrm>
+          <a:off x="0" y="0"/>
+          <a:ext cx="0" cy="0"/>
+          <a:chOff x="0" y="0"/>
+          <a:chExt cx="0" cy="0"/>
+        </a:xfrm>
+      </p:grpSpPr>
+      <p:sp>
+        <p:nvSpPr>
+          <p:cNvPr id="2" name="Slide Image Placeholder 1"/>
+          <p:cNvSpPr>
+            <a:spLocks noGrp="1"/>
+          </p:cNvSpPr>
+          <p:nvPr>
+            <p:ph type="sldImg" idx="2"/>
+          </p:nvPr>
+        </p:nvSpPr>
+        <p:spPr/>
+      </p:sp>
+      <p:sp>
+        <p:nvSpPr>
+          <p:cNvPr id="3" name="Notes Placeholder 2"/>
+          <p:cNvSpPr>
+            <a:spLocks noGrp="1"/>
+          </p:cNvSpPr>
+          <p:nvPr>
+            <p:ph type="body" idx="3" sz="quarter"/>
+          </p:nvPr>
+        </p:nvSpPr>
+        <p:spPr/>
+        <p:txBody>
+          <a:bodyPr/>
+          <a:lstStyle/>
+          <a:p>
+            <a:r>
+              <a:t>Owner briefing. The DOCX SOP contains triggers, steps, exit gates and required records. Confirmed workflow derives from user instructions. Proposed controls and unresolved authority remain marked; no live access transfer, owner acceptance or actual client records are implied.</a:t>
+            </a:r>
+          </a:p>
+        </p:txBody>
+      </p:sp>
+      <p:sp>
+        <p:nvSpPr>
+          <p:cNvPr id="4" name="Slide Number Placeholder 3"/>
+          <p:cNvSpPr>
+            <a:spLocks noGrp="1"/>
+          </p:cNvSpPr>
+          <p:nvPr>
+            <p:ph type="sldNum" idx="5" sz="quarter"/>
+          </p:nvPr>
+        </p:nvSpPr>
+        <p:spPr/>
+      </p:sp>
+    </p:spTree>
+  </p:cSld>
+  <p:clrMapOvr>
+    <a:masterClrMapping/>
+  </p:clrMapOvr>
+</p:notes>
+</file>
+
+<file path=ppt/notesSlides/notesSlide23.xml><?xml version="1.0" encoding="utf-8"?>
 <p:notes xmlns:a="http://schemas.openxmlformats.org/drawingml/2006/main" xmlns:p="http://schemas.openxmlformats.org/presentationml/2006/main" xmlns:r="http://schemas.openxmlformats.org/officeDocument/2006/relationships">
   <p:cSld>
     <p:spTree>
@@ -15132,6 +15203,875 @@
     <p:bg>
       <p:bgPr>
         <a:solidFill>
+          <a:srgbClr val="F3F1EE"/>
+        </a:solidFill>
+        <a:effectLst/>
+      </p:bgPr>
+    </p:bg>
+    <p:spTree>
+      <p:nvGrpSpPr>
+        <p:cNvPr id="1" name=""/>
+        <p:cNvGrpSpPr/>
+        <p:nvPr/>
+      </p:nvGrpSpPr>
+      <p:grpSpPr/>
+      <p:sp>
+        <p:nvSpPr>
+          <p:cNvPr id="2" name="TextBox 1"/>
+          <p:cNvSpPr txBox="1"/>
+          <p:nvPr/>
+        </p:nvSpPr>
+        <p:spPr>
+          <a:xfrm>
+            <a:off x="594360" y="274320"/>
+            <a:ext cx="1097280" cy="411480"/>
+          </a:xfrm>
+          <a:prstGeom prst="rect">
+            <a:avLst/>
+          </a:prstGeom>
+          <a:noFill/>
+        </p:spPr>
+        <p:txBody>
+          <a:bodyPr wrap="square" lIns="18288" rIns="18288" tIns="0" bIns="0">
+            <a:spAutoFit/>
+          </a:bodyPr>
+          <a:lstStyle/>
+          <a:p>
+            <a:pPr>
+              <a:spcAft>
+                <a:spcPts val="800"/>
+              </a:spcAft>
+              <a:defRPr sz="2500" b="1">
+                <a:solidFill>
+                  <a:srgbClr val="7D2B42"/>
+                </a:solidFill>
+                <a:latin typeface="Montserrat"/>
+              </a:defRPr>
+            </a:pPr>
+            <a:r>
+              <a:t>PMP</a:t>
+            </a:r>
+          </a:p>
+        </p:txBody>
+      </p:sp>
+      <p:sp>
+        <p:nvSpPr>
+          <p:cNvPr id="3" name="TextBox 2"/>
+          <p:cNvSpPr txBox="1"/>
+          <p:nvPr/>
+        </p:nvSpPr>
+        <p:spPr>
+          <a:xfrm>
+            <a:off x="1828800" y="384048"/>
+            <a:ext cx="10972800" cy="274320"/>
+          </a:xfrm>
+          <a:prstGeom prst="rect">
+            <a:avLst/>
+          </a:prstGeom>
+          <a:noFill/>
+        </p:spPr>
+        <p:txBody>
+          <a:bodyPr wrap="square" lIns="18288" rIns="18288" tIns="0" bIns="0">
+            <a:spAutoFit/>
+          </a:bodyPr>
+          <a:lstStyle/>
+          <a:p>
+            <a:pPr>
+              <a:spcAft>
+                <a:spcPts val="800"/>
+              </a:spcAft>
+              <a:defRPr sz="1000" b="1">
+                <a:solidFill>
+                  <a:srgbClr val="7D2B42"/>
+                </a:solidFill>
+                <a:latin typeface="Montserrat"/>
+              </a:defRPr>
+            </a:pPr>
+            <a:r>
+              <a:t>MARKETING DEPARTMENT / OWNER HANDOVER</a:t>
+            </a:r>
+          </a:p>
+        </p:txBody>
+      </p:sp>
+      <p:sp>
+        <p:nvSpPr>
+          <p:cNvPr id="4" name="Rectangle 3"/>
+          <p:cNvSpPr/>
+          <p:nvPr/>
+        </p:nvSpPr>
+        <p:spPr>
+          <a:xfrm>
+            <a:off x="640080" y="868680"/>
+            <a:ext cx="13350240" cy="13716"/>
+          </a:xfrm>
+          <a:prstGeom prst="rect">
+            <a:avLst/>
+          </a:prstGeom>
+          <a:solidFill>
+            <a:srgbClr val="7D2B42"/>
+          </a:solidFill>
+          <a:ln>
+            <a:noFill/>
+          </a:ln>
+        </p:spPr>
+        <p:style>
+          <a:lnRef idx="1">
+            <a:schemeClr val="accent1"/>
+          </a:lnRef>
+          <a:fillRef idx="3">
+            <a:schemeClr val="accent1"/>
+          </a:fillRef>
+          <a:effectRef idx="2">
+            <a:schemeClr val="accent1"/>
+          </a:effectRef>
+          <a:fontRef idx="minor">
+            <a:schemeClr val="lt1"/>
+          </a:fontRef>
+        </p:style>
+        <p:txBody>
+          <a:bodyPr rtlCol="0" anchor="ctr"/>
+          <a:lstStyle/>
+          <a:p>
+            <a:pPr algn="ctr"/>
+          </a:p>
+        </p:txBody>
+      </p:sp>
+      <p:sp>
+        <p:nvSpPr>
+          <p:cNvPr id="5" name="TextBox 4"/>
+          <p:cNvSpPr txBox="1"/>
+          <p:nvPr/>
+        </p:nvSpPr>
+        <p:spPr>
+          <a:xfrm>
+            <a:off x="685800" y="1188720"/>
+            <a:ext cx="13258800" cy="914400"/>
+          </a:xfrm>
+          <a:prstGeom prst="rect">
+            <a:avLst/>
+          </a:prstGeom>
+          <a:noFill/>
+        </p:spPr>
+        <p:txBody>
+          <a:bodyPr wrap="square" lIns="18288" rIns="18288" tIns="0" bIns="0">
+            <a:spAutoFit/>
+          </a:bodyPr>
+          <a:lstStyle/>
+          <a:p>
+            <a:pPr>
+              <a:spcAft>
+                <a:spcPts val="800"/>
+              </a:spcAft>
+              <a:defRPr sz="3800" b="1">
+                <a:solidFill>
+                  <a:srgbClr val="7D2B42"/>
+                </a:solidFill>
+                <a:latin typeface="Bebas Neue"/>
+              </a:defRPr>
+            </a:pPr>
+            <a:r>
+              <a:t>MONTHLY TEAM APPRAISALS / A DISTINCT OPERATING CYCLE</a:t>
+            </a:r>
+          </a:p>
+        </p:txBody>
+      </p:sp>
+      <p:sp>
+        <p:nvSpPr>
+          <p:cNvPr id="6" name="TextBox 5"/>
+          <p:cNvSpPr txBox="1"/>
+          <p:nvPr/>
+        </p:nvSpPr>
+        <p:spPr>
+          <a:xfrm>
+            <a:off x="685800" y="7772400"/>
+            <a:ext cx="10972800" cy="228600"/>
+          </a:xfrm>
+          <a:prstGeom prst="rect">
+            <a:avLst/>
+          </a:prstGeom>
+          <a:noFill/>
+        </p:spPr>
+        <p:txBody>
+          <a:bodyPr wrap="square" lIns="18288" rIns="18288" tIns="0" bIns="0">
+            <a:spAutoFit/>
+          </a:bodyPr>
+          <a:lstStyle/>
+          <a:p>
+            <a:pPr>
+              <a:spcAft>
+                <a:spcPts val="800"/>
+              </a:spcAft>
+              <a:defRPr sz="900" b="0">
+                <a:solidFill>
+                  <a:srgbClr val="555555"/>
+                </a:solidFill>
+                <a:latin typeface="Montserrat"/>
+              </a:defRPr>
+            </a:pPr>
+            <a:r>
+              <a:t>MODE OF OPERATIONS • V1.0 • OWNER ACCEPTANCE PENDING</a:t>
+            </a:r>
+          </a:p>
+        </p:txBody>
+      </p:sp>
+      <p:sp>
+        <p:nvSpPr>
+          <p:cNvPr id="7" name="TextBox 6"/>
+          <p:cNvSpPr txBox="1"/>
+          <p:nvPr/>
+        </p:nvSpPr>
+        <p:spPr>
+          <a:xfrm>
+            <a:off x="13350240" y="7726679"/>
+            <a:ext cx="594360" cy="274320"/>
+          </a:xfrm>
+          <a:prstGeom prst="rect">
+            <a:avLst/>
+          </a:prstGeom>
+          <a:noFill/>
+        </p:spPr>
+        <p:txBody>
+          <a:bodyPr wrap="square" lIns="18288" rIns="18288" tIns="0" bIns="0">
+            <a:spAutoFit/>
+          </a:bodyPr>
+          <a:lstStyle/>
+          <a:p>
+            <a:pPr>
+              <a:spcAft>
+                <a:spcPts val="800"/>
+              </a:spcAft>
+              <a:defRPr sz="1000" b="0">
+                <a:solidFill>
+                  <a:srgbClr val="7D2B42"/>
+                </a:solidFill>
+                <a:latin typeface="Montserrat"/>
+              </a:defRPr>
+            </a:pPr>
+            <a:r>
+              <a:t>22</a:t>
+            </a:r>
+          </a:p>
+        </p:txBody>
+      </p:sp>
+      <p:sp>
+        <p:nvSpPr>
+          <p:cNvPr id="8" name="Rectangle 7"/>
+          <p:cNvSpPr/>
+          <p:nvPr/>
+        </p:nvSpPr>
+        <p:spPr>
+          <a:xfrm>
+            <a:off x="731520" y="2331720"/>
+            <a:ext cx="3383280" cy="886968"/>
+          </a:xfrm>
+          <a:prstGeom prst="rect">
+            <a:avLst/>
+          </a:prstGeom>
+          <a:solidFill>
+            <a:srgbClr val="7D2B42"/>
+          </a:solidFill>
+          <a:ln>
+            <a:noFill/>
+          </a:ln>
+        </p:spPr>
+        <p:style>
+          <a:lnRef idx="1">
+            <a:schemeClr val="accent1"/>
+          </a:lnRef>
+          <a:fillRef idx="3">
+            <a:schemeClr val="accent1"/>
+          </a:fillRef>
+          <a:effectRef idx="2">
+            <a:schemeClr val="accent1"/>
+          </a:effectRef>
+          <a:fontRef idx="minor">
+            <a:schemeClr val="lt1"/>
+          </a:fontRef>
+        </p:style>
+        <p:txBody>
+          <a:bodyPr rtlCol="0" anchor="ctr"/>
+          <a:lstStyle/>
+          <a:p>
+            <a:pPr algn="ctr"/>
+          </a:p>
+        </p:txBody>
+      </p:sp>
+      <p:sp>
+        <p:nvSpPr>
+          <p:cNvPr id="9" name="TextBox 8"/>
+          <p:cNvSpPr txBox="1"/>
+          <p:nvPr/>
+        </p:nvSpPr>
+        <p:spPr>
+          <a:xfrm>
+            <a:off x="896112" y="2478024"/>
+            <a:ext cx="3054096" cy="758952"/>
+          </a:xfrm>
+          <a:prstGeom prst="rect">
+            <a:avLst/>
+          </a:prstGeom>
+          <a:noFill/>
+        </p:spPr>
+        <p:txBody>
+          <a:bodyPr wrap="square" lIns="18288" rIns="18288" tIns="0" bIns="0">
+            <a:spAutoFit/>
+          </a:bodyPr>
+          <a:lstStyle/>
+          <a:p>
+            <a:pPr>
+              <a:spcAft>
+                <a:spcPts val="800"/>
+              </a:spcAft>
+              <a:defRPr sz="1400" b="1">
+                <a:solidFill>
+                  <a:srgbClr val="FFFFFF"/>
+                </a:solidFill>
+                <a:latin typeface="Montserrat"/>
+              </a:defRPr>
+            </a:pPr>
+            <a:r>
+              <a:t>EVERY MONTH</a:t>
+            </a:r>
+          </a:p>
+        </p:txBody>
+      </p:sp>
+      <p:sp>
+        <p:nvSpPr>
+          <p:cNvPr id="10" name="TextBox 9"/>
+          <p:cNvSpPr txBox="1"/>
+          <p:nvPr/>
+        </p:nvSpPr>
+        <p:spPr>
+          <a:xfrm>
+            <a:off x="4389120" y="2423160"/>
+            <a:ext cx="9464040" cy="841248"/>
+          </a:xfrm>
+          <a:prstGeom prst="rect">
+            <a:avLst/>
+          </a:prstGeom>
+          <a:noFill/>
+        </p:spPr>
+        <p:txBody>
+          <a:bodyPr wrap="square" lIns="18288" rIns="18288" tIns="0" bIns="0">
+            <a:spAutoFit/>
+          </a:bodyPr>
+          <a:lstStyle/>
+          <a:p>
+            <a:pPr>
+              <a:spcAft>
+                <a:spcPts val="800"/>
+              </a:spcAft>
+              <a:defRPr sz="1700" b="0">
+                <a:solidFill>
+                  <a:srgbClr val="202020"/>
+                </a:solidFill>
+                <a:latin typeface="Montserrat"/>
+              </a:defRPr>
+            </a:pPr>
+            <a:r>
+              <a:t>Use approved role-specific forms; preserve private employee evidence and data.</a:t>
+            </a:r>
+          </a:p>
+        </p:txBody>
+      </p:sp>
+      <p:sp>
+        <p:nvSpPr>
+          <p:cNvPr id="11" name="Rectangle 10"/>
+          <p:cNvSpPr/>
+          <p:nvPr/>
+        </p:nvSpPr>
+        <p:spPr>
+          <a:xfrm>
+            <a:off x="731520" y="3337560"/>
+            <a:ext cx="3383280" cy="886968"/>
+          </a:xfrm>
+          <a:prstGeom prst="rect">
+            <a:avLst/>
+          </a:prstGeom>
+          <a:solidFill>
+            <a:srgbClr val="7D2B42"/>
+          </a:solidFill>
+          <a:ln>
+            <a:noFill/>
+          </a:ln>
+        </p:spPr>
+        <p:style>
+          <a:lnRef idx="1">
+            <a:schemeClr val="accent1"/>
+          </a:lnRef>
+          <a:fillRef idx="3">
+            <a:schemeClr val="accent1"/>
+          </a:fillRef>
+          <a:effectRef idx="2">
+            <a:schemeClr val="accent1"/>
+          </a:effectRef>
+          <a:fontRef idx="minor">
+            <a:schemeClr val="lt1"/>
+          </a:fontRef>
+        </p:style>
+        <p:txBody>
+          <a:bodyPr rtlCol="0" anchor="ctr"/>
+          <a:lstStyle/>
+          <a:p>
+            <a:pPr algn="ctr"/>
+          </a:p>
+        </p:txBody>
+      </p:sp>
+      <p:sp>
+        <p:nvSpPr>
+          <p:cNvPr id="12" name="TextBox 11"/>
+          <p:cNvSpPr txBox="1"/>
+          <p:nvPr/>
+        </p:nvSpPr>
+        <p:spPr>
+          <a:xfrm>
+            <a:off x="896112" y="3483864"/>
+            <a:ext cx="3054096" cy="758952"/>
+          </a:xfrm>
+          <a:prstGeom prst="rect">
+            <a:avLst/>
+          </a:prstGeom>
+          <a:noFill/>
+        </p:spPr>
+        <p:txBody>
+          <a:bodyPr wrap="square" lIns="18288" rIns="18288" tIns="0" bIns="0">
+            <a:spAutoFit/>
+          </a:bodyPr>
+          <a:lstStyle/>
+          <a:p>
+            <a:pPr>
+              <a:spcAft>
+                <a:spcPts val="800"/>
+              </a:spcAft>
+              <a:defRPr sz="1400" b="1">
+                <a:solidFill>
+                  <a:srgbClr val="FFFFFF"/>
+                </a:solidFill>
+                <a:latin typeface="Montserrat"/>
+              </a:defRPr>
+            </a:pPr>
+            <a:r>
+              <a:t>SELF + MANAGER</a:t>
+            </a:r>
+          </a:p>
+        </p:txBody>
+      </p:sp>
+      <p:sp>
+        <p:nvSpPr>
+          <p:cNvPr id="13" name="TextBox 12"/>
+          <p:cNvSpPr txBox="1"/>
+          <p:nvPr/>
+        </p:nvSpPr>
+        <p:spPr>
+          <a:xfrm>
+            <a:off x="4389120" y="3429000"/>
+            <a:ext cx="9464040" cy="841248"/>
+          </a:xfrm>
+          <a:prstGeom prst="rect">
+            <a:avLst/>
+          </a:prstGeom>
+          <a:noFill/>
+        </p:spPr>
+        <p:txBody>
+          <a:bodyPr wrap="square" lIns="18288" rIns="18288" tIns="0" bIns="0">
+            <a:spAutoFit/>
+          </a:bodyPr>
+          <a:lstStyle/>
+          <a:p>
+            <a:pPr>
+              <a:spcAft>
+                <a:spcPts val="800"/>
+              </a:spcAft>
+              <a:defRPr sz="1700" b="0">
+                <a:solidFill>
+                  <a:srgbClr val="202020"/>
+                </a:solidFill>
+                <a:latin typeface="Montserrat"/>
+              </a:defRPr>
+            </a:pPr>
+            <a:r>
+              <a:t>Employee self-rating before the meeting; manager rating and gap discussion.</a:t>
+            </a:r>
+          </a:p>
+        </p:txBody>
+      </p:sp>
+      <p:sp>
+        <p:nvSpPr>
+          <p:cNvPr id="14" name="Rectangle 13"/>
+          <p:cNvSpPr/>
+          <p:nvPr/>
+        </p:nvSpPr>
+        <p:spPr>
+          <a:xfrm>
+            <a:off x="731520" y="4343400"/>
+            <a:ext cx="3383280" cy="886968"/>
+          </a:xfrm>
+          <a:prstGeom prst="rect">
+            <a:avLst/>
+          </a:prstGeom>
+          <a:solidFill>
+            <a:srgbClr val="7D2B42"/>
+          </a:solidFill>
+          <a:ln>
+            <a:noFill/>
+          </a:ln>
+        </p:spPr>
+        <p:style>
+          <a:lnRef idx="1">
+            <a:schemeClr val="accent1"/>
+          </a:lnRef>
+          <a:fillRef idx="3">
+            <a:schemeClr val="accent1"/>
+          </a:fillRef>
+          <a:effectRef idx="2">
+            <a:schemeClr val="accent1"/>
+          </a:effectRef>
+          <a:fontRef idx="minor">
+            <a:schemeClr val="lt1"/>
+          </a:fontRef>
+        </p:style>
+        <p:txBody>
+          <a:bodyPr rtlCol="0" anchor="ctr"/>
+          <a:lstStyle/>
+          <a:p>
+            <a:pPr algn="ctr"/>
+          </a:p>
+        </p:txBody>
+      </p:sp>
+      <p:sp>
+        <p:nvSpPr>
+          <p:cNvPr id="15" name="TextBox 14"/>
+          <p:cNvSpPr txBox="1"/>
+          <p:nvPr/>
+        </p:nvSpPr>
+        <p:spPr>
+          <a:xfrm>
+            <a:off x="896112" y="4489704"/>
+            <a:ext cx="3054096" cy="758952"/>
+          </a:xfrm>
+          <a:prstGeom prst="rect">
+            <a:avLst/>
+          </a:prstGeom>
+          <a:noFill/>
+        </p:spPr>
+        <p:txBody>
+          <a:bodyPr wrap="square" lIns="18288" rIns="18288" tIns="0" bIns="0">
+            <a:spAutoFit/>
+          </a:bodyPr>
+          <a:lstStyle/>
+          <a:p>
+            <a:pPr>
+              <a:spcAft>
+                <a:spcPts val="800"/>
+              </a:spcAft>
+              <a:defRPr sz="1400" b="1">
+                <a:solidFill>
+                  <a:srgbClr val="FFFFFF"/>
+                </a:solidFill>
+                <a:latin typeface="Montserrat"/>
+              </a:defRPr>
+            </a:pPr>
+            <a:r>
+              <a:t>WEIGHTS / SCALE</a:t>
+            </a:r>
+          </a:p>
+        </p:txBody>
+      </p:sp>
+      <p:sp>
+        <p:nvSpPr>
+          <p:cNvPr id="16" name="TextBox 15"/>
+          <p:cNvSpPr txBox="1"/>
+          <p:nvPr/>
+        </p:nvSpPr>
+        <p:spPr>
+          <a:xfrm>
+            <a:off x="4389120" y="4434840"/>
+            <a:ext cx="9464040" cy="841248"/>
+          </a:xfrm>
+          <a:prstGeom prst="rect">
+            <a:avLst/>
+          </a:prstGeom>
+          <a:noFill/>
+        </p:spPr>
+        <p:txBody>
+          <a:bodyPr wrap="square" lIns="18288" rIns="18288" tIns="0" bIns="0">
+            <a:spAutoFit/>
+          </a:bodyPr>
+          <a:lstStyle/>
+          <a:p>
+            <a:pPr>
+              <a:spcAft>
+                <a:spcPts val="800"/>
+              </a:spcAft>
+              <a:defRPr sz="1700" b="0">
+                <a:solidFill>
+                  <a:srgbClr val="202020"/>
+                </a:solidFill>
+                <a:latin typeface="Montserrat"/>
+              </a:defRPr>
+            </a:pPr>
+            <a:r>
+              <a:t>30% core, 50% role KPIs, 10% development, 10% culture. Scale 1–5; justify 1/2/5.</a:t>
+            </a:r>
+          </a:p>
+        </p:txBody>
+      </p:sp>
+      <p:sp>
+        <p:nvSpPr>
+          <p:cNvPr id="17" name="Rectangle 16"/>
+          <p:cNvSpPr/>
+          <p:nvPr/>
+        </p:nvSpPr>
+        <p:spPr>
+          <a:xfrm>
+            <a:off x="731520" y="5349240"/>
+            <a:ext cx="3383280" cy="886968"/>
+          </a:xfrm>
+          <a:prstGeom prst="rect">
+            <a:avLst/>
+          </a:prstGeom>
+          <a:solidFill>
+            <a:srgbClr val="7D2B42"/>
+          </a:solidFill>
+          <a:ln>
+            <a:noFill/>
+          </a:ln>
+        </p:spPr>
+        <p:style>
+          <a:lnRef idx="1">
+            <a:schemeClr val="accent1"/>
+          </a:lnRef>
+          <a:fillRef idx="3">
+            <a:schemeClr val="accent1"/>
+          </a:fillRef>
+          <a:effectRef idx="2">
+            <a:schemeClr val="accent1"/>
+          </a:effectRef>
+          <a:fontRef idx="minor">
+            <a:schemeClr val="lt1"/>
+          </a:fontRef>
+        </p:style>
+        <p:txBody>
+          <a:bodyPr rtlCol="0" anchor="ctr"/>
+          <a:lstStyle/>
+          <a:p>
+            <a:pPr algn="ctr"/>
+          </a:p>
+        </p:txBody>
+      </p:sp>
+      <p:sp>
+        <p:nvSpPr>
+          <p:cNvPr id="18" name="TextBox 17"/>
+          <p:cNvSpPr txBox="1"/>
+          <p:nvPr/>
+        </p:nvSpPr>
+        <p:spPr>
+          <a:xfrm>
+            <a:off x="896112" y="5495544"/>
+            <a:ext cx="3054096" cy="758952"/>
+          </a:xfrm>
+          <a:prstGeom prst="rect">
+            <a:avLst/>
+          </a:prstGeom>
+          <a:noFill/>
+        </p:spPr>
+        <p:txBody>
+          <a:bodyPr wrap="square" lIns="18288" rIns="18288" tIns="0" bIns="0">
+            <a:spAutoFit/>
+          </a:bodyPr>
+          <a:lstStyle/>
+          <a:p>
+            <a:pPr>
+              <a:spcAft>
+                <a:spcPts val="800"/>
+              </a:spcAft>
+              <a:defRPr sz="1400" b="1">
+                <a:solidFill>
+                  <a:srgbClr val="FFFFFF"/>
+                </a:solidFill>
+                <a:latin typeface="Montserrat"/>
+              </a:defRPr>
+            </a:pPr>
+            <a:r>
+              <a:t>DEVELOPMENT</a:t>
+            </a:r>
+          </a:p>
+        </p:txBody>
+      </p:sp>
+      <p:sp>
+        <p:nvSpPr>
+          <p:cNvPr id="19" name="TextBox 18"/>
+          <p:cNvSpPr txBox="1"/>
+          <p:nvPr/>
+        </p:nvSpPr>
+        <p:spPr>
+          <a:xfrm>
+            <a:off x="4389120" y="5440679"/>
+            <a:ext cx="9464040" cy="841248"/>
+          </a:xfrm>
+          <a:prstGeom prst="rect">
+            <a:avLst/>
+          </a:prstGeom>
+          <a:noFill/>
+        </p:spPr>
+        <p:txBody>
+          <a:bodyPr wrap="square" lIns="18288" rIns="18288" tIns="0" bIns="0">
+            <a:spAutoFit/>
+          </a:bodyPr>
+          <a:lstStyle/>
+          <a:p>
+            <a:pPr>
+              <a:spcAft>
+                <a:spcPts val="800"/>
+              </a:spcAft>
+              <a:defRPr sz="1700" b="0">
+                <a:solidFill>
+                  <a:srgbClr val="202020"/>
+                </a:solidFill>
+                <a:latin typeface="Montserrat"/>
+              </a:defRPr>
+            </a:pPr>
+            <a:r>
+              <a:t>Record achievements, blockers, feedback and next SMART goals; follow quarterly OKRs monthly.</a:t>
+            </a:r>
+          </a:p>
+        </p:txBody>
+      </p:sp>
+      <p:sp>
+        <p:nvSpPr>
+          <p:cNvPr id="20" name="Rectangle 19"/>
+          <p:cNvSpPr/>
+          <p:nvPr/>
+        </p:nvSpPr>
+        <p:spPr>
+          <a:xfrm>
+            <a:off x="731520" y="6355080"/>
+            <a:ext cx="3383280" cy="886968"/>
+          </a:xfrm>
+          <a:prstGeom prst="rect">
+            <a:avLst/>
+          </a:prstGeom>
+          <a:solidFill>
+            <a:srgbClr val="7D2B42"/>
+          </a:solidFill>
+          <a:ln>
+            <a:noFill/>
+          </a:ln>
+        </p:spPr>
+        <p:style>
+          <a:lnRef idx="1">
+            <a:schemeClr val="accent1"/>
+          </a:lnRef>
+          <a:fillRef idx="3">
+            <a:schemeClr val="accent1"/>
+          </a:fillRef>
+          <a:effectRef idx="2">
+            <a:schemeClr val="accent1"/>
+          </a:effectRef>
+          <a:fontRef idx="minor">
+            <a:schemeClr val="lt1"/>
+          </a:fontRef>
+        </p:style>
+        <p:txBody>
+          <a:bodyPr rtlCol="0" anchor="ctr"/>
+          <a:lstStyle/>
+          <a:p>
+            <a:pPr algn="ctr"/>
+          </a:p>
+        </p:txBody>
+      </p:sp>
+      <p:sp>
+        <p:nvSpPr>
+          <p:cNvPr id="21" name="TextBox 20"/>
+          <p:cNvSpPr txBox="1"/>
+          <p:nvPr/>
+        </p:nvSpPr>
+        <p:spPr>
+          <a:xfrm>
+            <a:off x="896112" y="6501384"/>
+            <a:ext cx="3054096" cy="758952"/>
+          </a:xfrm>
+          <a:prstGeom prst="rect">
+            <a:avLst/>
+          </a:prstGeom>
+          <a:noFill/>
+        </p:spPr>
+        <p:txBody>
+          <a:bodyPr wrap="square" lIns="18288" rIns="18288" tIns="0" bIns="0">
+            <a:spAutoFit/>
+          </a:bodyPr>
+          <a:lstStyle/>
+          <a:p>
+            <a:pPr>
+              <a:spcAft>
+                <a:spcPts val="800"/>
+              </a:spcAft>
+              <a:defRPr sz="1400" b="1">
+                <a:solidFill>
+                  <a:srgbClr val="FFFFFF"/>
+                </a:solidFill>
+                <a:latin typeface="Montserrat"/>
+              </a:defRPr>
+            </a:pPr>
+            <a:r>
+              <a:t>COMPLETENESS</a:t>
+            </a:r>
+          </a:p>
+        </p:txBody>
+      </p:sp>
+      <p:sp>
+        <p:nvSpPr>
+          <p:cNvPr id="22" name="TextBox 21"/>
+          <p:cNvSpPr txBox="1"/>
+          <p:nvPr/>
+        </p:nvSpPr>
+        <p:spPr>
+          <a:xfrm>
+            <a:off x="4389120" y="6446520"/>
+            <a:ext cx="9464040" cy="841248"/>
+          </a:xfrm>
+          <a:prstGeom prst="rect">
+            <a:avLst/>
+          </a:prstGeom>
+          <a:noFill/>
+        </p:spPr>
+        <p:txBody>
+          <a:bodyPr wrap="square" lIns="18288" rIns="18288" tIns="0" bIns="0">
+            <a:spAutoFit/>
+          </a:bodyPr>
+          <a:lstStyle/>
+          <a:p>
+            <a:pPr>
+              <a:spcAft>
+                <a:spcPts val="800"/>
+              </a:spcAft>
+              <a:defRPr sz="1700" b="0">
+                <a:solidFill>
+                  <a:srgbClr val="202020"/>
+                </a:solidFill>
+                <a:latin typeface="Montserrat"/>
+              </a:defRPr>
+            </a:pPr>
+            <a:r>
+              <a:t>Do not interpret blank-as-zero totals as completed reviews or make pay/promotion automatic.</a:t>
+            </a:r>
+          </a:p>
+        </p:txBody>
+      </p:sp>
+    </p:spTree>
+  </p:cSld>
+  <p:clrMapOvr>
+    <a:masterClrMapping/>
+  </p:clrMapOvr>
+</p:sld>
+</file>
+
+<file path=ppt/slides/slide23.xml><?xml version="1.0" encoding="utf-8"?>
+<p:sld xmlns:a="http://schemas.openxmlformats.org/drawingml/2006/main" xmlns:p="http://schemas.openxmlformats.org/presentationml/2006/main" xmlns:r="http://schemas.openxmlformats.org/officeDocument/2006/relationships">
+  <p:cSld>
+    <p:bg>
+      <p:bgPr>
+        <a:solidFill>
           <a:srgbClr val="7D2B42"/>
         </a:solidFill>
         <a:effectLst/>
@@ -15377,7 +16317,7 @@
               </a:defRPr>
             </a:pPr>
             <a:r>
-              <a:t>22</a:t>
+              <a:t>23</a:t>
             </a:r>
           </a:p>
         </p:txBody>

</xml_diff>